<commit_message>
docs: presentación — lámina 88 (Consolidar) con prompt entendible para no técnicos (comando /cierre) y resultado simplificado
</commit_message>
<xml_diff>
--- a/Taller-Claude-Yuri.pptx
+++ b/Taller-Claude-Yuri.pptx
@@ -30329,7 +30329,7 @@
                 <a:ea typeface="Calibri" pitchFamily="34" charset="-122"/>
                 <a:cs typeface="Calibri" pitchFamily="34" charset="-120"/>
               </a:rPr>
-              <a:t>Objetivo: salir con el proceso reutilizable (handoff + memoria) y una pieza propia funcionando.</a:t>
+              <a:t>Objetivo: dejar el proyecto listo para retomar (resumen + memoria) y crear tu primera pieza propia: un comando.</a:t>
             </a:r>
             <a:endParaRPr lang="en-US" sz="1450" dirty="0"/>
           </a:p>
@@ -30379,7 +30379,7 @@
                 <a:ea typeface="Calibri" pitchFamily="34" charset="-122"/>
                 <a:cs typeface="Calibri" pitchFamily="34" charset="-120"/>
               </a:rPr>
-              <a:t>el kit (/optimizar-memoria + ESTADO.md) + un estándar de tu lenguaje en mente.</a:t>
+              <a:t>el kit (/optimizar-memoria + ESTADO.md). Un comando es solo un archivo de texto; no hay que programar.</a:t>
             </a:r>
             <a:endParaRPr lang="en-US" sz="1200" dirty="0"/>
           </a:p>
@@ -30461,7 +30461,7 @@
                 <a:ea typeface="Calibri" pitchFamily="34" charset="-122"/>
                 <a:cs typeface="Calibri" pitchFamily="34" charset="-120"/>
               </a:rPr>
-              <a:t>Actualiza ESTADO.md con el handoff (etapa, hecho, próximo paso).</a:t>
+              <a:t>Actualiza ESTADO.md con el resumen de hoy (etapa, qué se logró, próximo paso).</a:t>
             </a:r>
             <a:endParaRPr lang="en-US" sz="1300" dirty="0"/>
           </a:p>
@@ -30482,7 +30482,7 @@
                 <a:ea typeface="Calibri" pitchFamily="34" charset="-122"/>
                 <a:cs typeface="Calibri" pitchFamily="34" charset="-120"/>
               </a:rPr>
-              <a:t>Corre /optimizar-memoria y revisa las podas propuestas.</a:t>
+              <a:t>Corre /optimizar-memoria y revisa qué propone quitar.</a:t>
             </a:r>
             <a:endParaRPr lang="en-US" sz="1300" dirty="0"/>
           </a:p>
@@ -30503,7 +30503,7 @@
                 <a:ea typeface="Calibri" pitchFamily="34" charset="-122"/>
                 <a:cs typeface="Calibri" pitchFamily="34" charset="-120"/>
               </a:rPr>
-              <a:t>Crea una skill/command para tu stack y pruébala.</a:t>
+              <a:t>Crea tu propio comando /cierre y pruébalo escribiéndolo.</a:t>
             </a:r>
             <a:endParaRPr lang="en-US" sz="1300" dirty="0"/>
           </a:p>
@@ -30574,7 +30574,7 @@
                 <a:ea typeface="Consolas" pitchFamily="34" charset="-122"/>
                 <a:cs typeface="Consolas" pitchFamily="34" charset="-120"/>
               </a:rPr>
-              <a:t>Cierre. 1) Reescribe ESTADO.md: Etapa = asegurar; Hecho = IDOR corregido y verify pasa (12 pruebas); Próximo = una acción que elijas. 2) Corre /optimizar-memoria y lista qué de CLAUDE.md y memory/MEMORY.md es plantilla o ya no aplica; NO borres, solo propón. 3) Crea una skill en .claude/skills/ para JavaScript que revise "toda llamada a async usa await o maneja la promesa". Con una description que se auto-invoque al editar un .js. Pruébala con un .js con el error: se activa sola. verify sigue pasando.</a:t>
+              <a:t>Cierre del proyecto. 1) Reescribe ESTADO.md con el resumen de hoy: en qué etapa quedamos (asegurar), qué se logró (arreglamos el hueco de seguridad y las pruebas pasan) y el próximo paso. 2) Corre /optimizar-memoria y muéstrame qué de CLAUDE.md y memory/ ya sobra o es plantilla; no borres nada, solo propón. 3) Ahora hazlo tuyo: crea un comando nuevo llamado /cierre —es solo un archivo en .claude/commands/— que, al escribirlo, actualice ESTADO.md con el resumen del día. Créalo y pruébalo escribiendo /cierre.</a:t>
             </a:r>
             <a:endParaRPr lang="en-US" sz="1150" dirty="0"/>
           </a:p>
@@ -30656,7 +30656,7 @@
                 <a:ea typeface="Calibri" pitchFamily="34" charset="-122"/>
                 <a:cs typeface="Calibri" pitchFamily="34" charset="-120"/>
               </a:rPr>
-              <a:t>ESTADO.md queda al día (retomable en otra sesión/modelo).</a:t>
+              <a:t>ESTADO.md queda con el resumen de hoy: etapa, qué se logró y próximo paso.</a:t>
             </a:r>
             <a:endParaRPr lang="en-US" sz="1250" dirty="0"/>
           </a:p>
@@ -30677,7 +30677,7 @@
                 <a:ea typeface="Calibri" pitchFamily="34" charset="-122"/>
                 <a:cs typeface="Calibri" pitchFamily="34" charset="-120"/>
               </a:rPr>
-              <a:t>/optimizar-memoria propone quitar obsoleto y fusionar duplicados (espera tu OK).</a:t>
+              <a:t>/optimizar-memoria te propone qué quitar de CLAUDE.md y memory/ (tú apruebas; no borra solo).</a:t>
             </a:r>
             <a:endParaRPr lang="en-US" sz="1250" dirty="0"/>
           </a:p>
@@ -30698,7 +30698,7 @@
                 <a:ea typeface="Calibri" pitchFamily="34" charset="-122"/>
                 <a:cs typeface="Calibri" pitchFamily="34" charset="-120"/>
               </a:rPr>
-              <a:t>La nueva skill tiene una descripción que la auto-invoca; se activa en un caso real.</a:t>
+              <a:t>Tu comando /cierre existe (un archivo en .claude/commands/) y funciona al escribirlo.</a:t>
             </a:r>
             <a:endParaRPr lang="en-US" sz="1250" dirty="0"/>
           </a:p>
@@ -30719,7 +30719,7 @@
                 <a:ea typeface="Calibri" pitchFamily="34" charset="-122"/>
                 <a:cs typeface="Calibri" pitchFamily="34" charset="-120"/>
               </a:rPr>
-              <a:t>CLAUDE.md queda más corto y veraz; npm run verify sigue aprobado.</a:t>
+              <a:t>Sales con el proyecto listo para retomar y con tu primera pieza propia.</a:t>
             </a:r>
             <a:endParaRPr lang="en-US" sz="1250" dirty="0"/>
           </a:p>

</xml_diff>